<commit_message>
GCG July deck: Renzo analytical review, 9 corrections + spend-basis unification
Opener leads the business problem (funded -38.5%, traded -41.5%); cost
rows renamed Media Spend / Blended Funded-Traded with directional-ratio
caveat (clears both WARNs); $1 rounding footnote; Search headline and
rank language corrected (impression share lost to rank); Azerion detail
tables scaled to tracker basis (weekly + audience sum $31,477 exactly,
vendor originals in qa); Native verdicts MAINTAIN/CONTINUE TEST on
clustered CTRs; GA4 organic claim scoped to evidence; funnel cohort
caveat + explicit 47.1%->40.1% statement; closer attribution corrected
to 202 = half of blended (named §1 exception). Rulings codified in
DOCTRINE §3.

Co-Authored-By: Claude Fable 5 <noreply@anthropic.com>
</commit_message>
<xml_diff>
--- a/reports/forex/gcg/2026-07/output/GCG_US_July_2026_Performance_Review.pptx
+++ b/reports/forex/gcg/2026-07/output/GCG_US_July_2026_Performance_Review.pptx
@@ -3904,7 +3904,7 @@
                           </a:solidFill>
                           <a:latin typeface="Calibri"/>
                         </a:rPr>
-                        <a:t>$197.43</a:t>
+                        <a:t>$217.17</a:t>
                       </a:r>
                     </a:p>
                   </a:txBody>
@@ -3998,7 +3998,7 @@
                           </a:solidFill>
                           <a:latin typeface="Calibri"/>
                         </a:rPr>
-                        <a:t>$267.58</a:t>
+                        <a:t>$294.31</a:t>
                       </a:r>
                     </a:p>
                   </a:txBody>
@@ -4092,7 +4092,7 @@
                           </a:solidFill>
                           <a:latin typeface="Calibri"/>
                         </a:rPr>
-                        <a:t>$312.01</a:t>
+                        <a:t>$343.18</a:t>
                       </a:r>
                     </a:p>
                   </a:txBody>
@@ -4186,7 +4186,7 @@
                           </a:solidFill>
                           <a:latin typeface="Calibri"/>
                         </a:rPr>
-                        <a:t>$316.36</a:t>
+                        <a:t>$348.00</a:t>
                       </a:r>
                     </a:p>
                   </a:txBody>
@@ -4280,7 +4280,7 @@
                           </a:solidFill>
                           <a:latin typeface="Calibri"/>
                         </a:rPr>
-                        <a:t>$420.48</a:t>
+                        <a:t>$462.50</a:t>
                       </a:r>
                     </a:p>
                   </a:txBody>
@@ -4374,7 +4374,7 @@
                           </a:solidFill>
                           <a:latin typeface="Calibri"/>
                         </a:rPr>
-                        <a:t>$812.31</a:t>
+                        <a:t>$893.67</a:t>
                       </a:r>
                     </a:p>
                   </a:txBody>
@@ -5150,7 +5150,7 @@
                           </a:solidFill>
                           <a:latin typeface="Calibri"/>
                         </a:rPr>
-                        <a:t>SCALE</a:t>
+                        <a:t>MAINTAIN</a:t>
                       </a:r>
                     </a:p>
                   </a:txBody>
@@ -5267,7 +5267,7 @@
                           </a:solidFill>
                           <a:latin typeface="Calibri"/>
                         </a:rPr>
-                        <a:t>SCALE</a:t>
+                        <a:t>MAINTAIN</a:t>
                       </a:r>
                     </a:p>
                   </a:txBody>
@@ -5384,7 +5384,7 @@
                           </a:solidFill>
                           <a:latin typeface="Calibri"/>
                         </a:rPr>
-                        <a:t>RETAIN-TEST</a:t>
+                        <a:t>CONTINUE TEST</a:t>
                       </a:r>
                     </a:p>
                   </a:txBody>
@@ -5501,7 +5501,7 @@
                           </a:solidFill>
                           <a:latin typeface="Calibri"/>
                         </a:rPr>
-                        <a:t>RETAIN-TEST</a:t>
+                        <a:t>CONTINUE TEST</a:t>
                       </a:r>
                     </a:p>
                   </a:txBody>
@@ -5618,7 +5618,7 @@
                           </a:solidFill>
                           <a:latin typeface="Calibri"/>
                         </a:rPr>
-                        <a:t>RETAIN-TEST</a:t>
+                        <a:t>CONTINUE TEST</a:t>
                       </a:r>
                     </a:p>
                   </a:txBody>
@@ -5735,7 +5735,7 @@
                           </a:solidFill>
                           <a:latin typeface="Calibri"/>
                         </a:rPr>
-                        <a:t>RETAIN-TEST</a:t>
+                        <a:t>CONTINUE TEST</a:t>
                       </a:r>
                     </a:p>
                   </a:txBody>
@@ -5956,7 +5956,7 @@
                 </a:solidFill>
                 <a:latin typeface="Calibri"/>
               </a:rPr>
-              <a:t>DECISION: scale the two strongest creatives by click-through rate, City_view_MHTN and Mobile_desktop_view; hold the rest for a second month before any removal, this is the line’s first full month.</a:t>
+              <a:t>DECISION: creative performance was tightly clustered. Maintain the leading creatives at a modestly higher weight and continue testing before removing the others.</a:t>
             </a:r>
           </a:p>
         </p:txBody>
@@ -7226,7 +7226,7 @@
                 </a:solidFill>
                 <a:latin typeface="Calibri"/>
               </a:rPr>
-              <a:t>This isn’t a decline in unpaid (organic) traffic; the softness tracks the paid pullback.</a:t>
+              <a:t>The decline is consistent with the Meta spend reduction, but the GA4 source and medium breakdown is needed to confirm how much came from paid versus unpaid traffic.</a:t>
             </a:r>
           </a:p>
           <a:p>
@@ -9018,8 +9018,8 @@
         </p:nvSpPr>
         <p:spPr>
           <a:xfrm>
-            <a:off x="457200" y="5212080"/>
-            <a:ext cx="11274552" cy="1097280"/>
+            <a:off x="457200" y="5074920"/>
+            <a:ext cx="11274552" cy="1417320"/>
           </a:xfrm>
           <a:prstGeom prst="rect">
             <a:avLst/>
@@ -9064,8 +9064,8 @@
         </p:nvSpPr>
         <p:spPr>
           <a:xfrm>
-            <a:off x="457200" y="5212080"/>
-            <a:ext cx="64008" cy="1097280"/>
+            <a:off x="457200" y="5074920"/>
+            <a:ext cx="64008" cy="1417320"/>
           </a:xfrm>
           <a:prstGeom prst="rect">
             <a:avLst/>
@@ -9108,7 +9108,7 @@
         </p:nvSpPr>
         <p:spPr>
           <a:xfrm>
-            <a:off x="676656" y="5376672"/>
+            <a:off x="676656" y="5239512"/>
             <a:ext cx="10872216" cy="274320"/>
           </a:xfrm>
           <a:prstGeom prst="rect">
@@ -9143,8 +9143,8 @@
         </p:nvSpPr>
         <p:spPr>
           <a:xfrm>
-            <a:off x="676656" y="5715000"/>
-            <a:ext cx="10872216" cy="411479"/>
+            <a:off x="676656" y="5577840"/>
+            <a:ext cx="10872216" cy="731520"/>
           </a:xfrm>
           <a:prstGeom prst="rect">
             <a:avLst/>
@@ -9165,7 +9165,7 @@
                 </a:solidFill>
                 <a:latin typeface="Calibri"/>
               </a:rPr>
-              <a:t>Approvals rose 5.9% to 162, growing with the application volume; the approval rate came in at 40.1% as the application base grew faster. Funding is the step to watch: 32 accounts at a 19.8% rate against Q2’s 34.5% average, and 24 traded against June’s 41. Approval, funding and activation are FOREX.com’s application review and account-activation process.</a:t>
+              <a:t>Approved applications rose 5.9% to 162. The approval rate fell from 47.1% to 40.1%: approvals did not keep pace with submission growth.</a:t>
             </a:r>
           </a:p>
           <a:p>
@@ -9181,7 +9181,39 @@
                 </a:solidFill>
                 <a:latin typeface="Calibri"/>
               </a:rPr>
-              <a:t>TAKEAWAY: the top of the funnel is converting more efficiently on fewer sessions; the funding rate is the step to monitor next cycle.</a:t>
+              <a:t>Funding came in at 32, a 19.8% rate against Q2’s 34.5% average, and 24 accounts traded against June’s 41.</a:t>
+            </a:r>
+          </a:p>
+          <a:p>
+            <a:pPr algn="l">
+              <a:spcBef>
+                <a:spcPts val="600"/>
+              </a:spcBef>
+            </a:pPr>
+            <a:r>
+              <a:rPr sz="950" b="0">
+                <a:solidFill>
+                  <a:srgbClr val="2B3147"/>
+                </a:solidFill>
+                <a:latin typeface="Calibri"/>
+              </a:rPr>
+              <a:t>Approval and funding are downstream stages in the blended funnel. Source-level cohort data is needed to determine whether the decline reflects application quality, processing time, conversion lag, or account activation.</a:t>
+            </a:r>
+          </a:p>
+          <a:p>
+            <a:pPr algn="l">
+              <a:spcBef>
+                <a:spcPts val="600"/>
+              </a:spcBef>
+            </a:pPr>
+            <a:r>
+              <a:rPr sz="950" b="0">
+                <a:solidFill>
+                  <a:srgbClr val="2B3147"/>
+                </a:solidFill>
+                <a:latin typeface="Calibri"/>
+              </a:rPr>
+              <a:t>Approval and funding can occur after the submission month; July rates should be treated as an operating indicator until the application cohort matures.</a:t>
             </a:r>
           </a:p>
         </p:txBody>
@@ -9655,7 +9687,7 @@
                 </a:solidFill>
                 <a:latin typeface="Calibri"/>
               </a:rPr>
-              <a:t>Extend the same ad-position work to Track B Authority and Platform.</a:t>
+              <a:t>Track A Trust improved after the July changes. Extend the same controlled test to Authority and Platform.</a:t>
             </a:r>
           </a:p>
           <a:p>
@@ -9671,23 +9703,7 @@
                 </a:solidFill>
                 <a:latin typeface="Calibri"/>
               </a:rPr>
-              <a:t>Track A Trust proves it works: our ads show up more often in relevant searches, they lose the auction to competitors less, cost per application is down, and it’s now the top-performing group.</a:t>
-            </a:r>
-          </a:p>
-          <a:p>
-            <a:pPr algn="l">
-              <a:spcBef>
-                <a:spcPts val="600"/>
-              </a:spcBef>
-            </a:pPr>
-            <a:r>
-              <a:rPr sz="900" b="0">
-                <a:solidFill>
-                  <a:srgbClr val="2B3147"/>
-                </a:solidFill>
-                <a:latin typeface="Calibri"/>
-              </a:rPr>
-              <a:t>The other two groups still lose the auction to competitors 63 to 70% of the time.</a:t>
+              <a:t>The other two groups still lose 63 to 70% of impression share due to rank.</a:t>
             </a:r>
           </a:p>
         </p:txBody>
@@ -10294,7 +10310,7 @@
                 </a:solidFill>
                 <a:latin typeface="Georgia"/>
               </a:rPr>
-              <a:t>Google’s two lines and Azerion produced the month’s application volume through what’s already working; August scales it further.</a:t>
+              <a:t>Google and Azerion produced 202 directly measured applications, representing half of July’s blended submissions. August should extend the strongest tests while monitoring CPA and downstream quality.</a:t>
             </a:r>
           </a:p>
         </p:txBody>
@@ -10494,7 +10510,7 @@
                 </a:solidFill>
                 <a:latin typeface="Georgia"/>
               </a:rPr>
-              <a:t>Submitted applications came in at 404, up 24.3%, with working media at $136,224.</a:t>
+              <a:t>Submitted applications rose 24.3%, but funded accounts fell 38.5% and traded accounts fell 41.5%.</a:t>
             </a:r>
           </a:p>
         </p:txBody>
@@ -10691,7 +10707,7 @@
                 </a:solidFill>
                 <a:latin typeface="Calibri"/>
               </a:rPr>
-              <a:t>Approved applications rose 5.9% to 162, growing with the application volume; the approval rate came in at 40.1% as the application base grew faster. Funded accounts came in at 32, a 19.8% rate against Q2’s 34.5% average, a step that happens inside FOREX.com’s application-review process after media’s handoff.</a:t>
+              <a:t>Approved applications rose 5.9% to 162, growing with the application volume; the approval rate came in at 40.1% as the application base grew faster. Funded accounts came in at 32, a 19.8% rate against Q2’s 34.5% average. Approval and funding are downstream stages in the blended funnel. Source-level cohort data is needed to determine whether the decline reflects application quality, processing time, conversion lag, or account activation.</a:t>
             </a:r>
           </a:p>
           <a:p>
@@ -12636,7 +12652,7 @@
                           </a:solidFill>
                           <a:latin typeface="Calibri"/>
                         </a:rPr>
-                        <a:t>Cost per Funded</a:t>
+                        <a:t>Media Spend / Blended Funded</a:t>
                       </a:r>
                     </a:p>
                   </a:txBody>
@@ -13054,7 +13070,7 @@
                           </a:solidFill>
                           <a:latin typeface="Calibri"/>
                         </a:rPr>
-                        <a:t>Cost per Traded</a:t>
+                        <a:t>Media Spend / Blended Traded</a:t>
                       </a:r>
                     </a:p>
                   </a:txBody>
@@ -13262,7 +13278,7 @@
         <p:spPr>
           <a:xfrm>
             <a:off x="457200" y="5623560"/>
-            <a:ext cx="11247120" cy="457200"/>
+            <a:ext cx="11247120" cy="548640"/>
           </a:xfrm>
           <a:prstGeom prst="rect">
             <a:avLst/>
@@ -13283,7 +13299,7 @@
                 </a:solidFill>
                 <a:latin typeface="Calibri"/>
               </a:rPr>
-              <a:t>Funnel metrics are blended organic + paid from the FOREX.com dashboard. Media spend comes from the FOREX.com budget tracker. MoM = July vs June. January-February cost rows reflect a near-zero media base; the paid-media baseline starts in March.</a:t>
+              <a:t>Funnel metrics are blended organic + paid from the FOREX.com dashboard. Media spend comes from the FOREX.com budget tracker. MoM = July vs June. January-February cost rows reflect a near-zero media base; the paid-media baseline starts in March. These are directional spend-to-outcome ratios, not channel-attributed CPAs.</a:t>
             </a:r>
           </a:p>
         </p:txBody>
@@ -14782,7 +14798,7 @@
                 </a:solidFill>
                 <a:latin typeface="Calibri"/>
               </a:rPr>
-              <a:t>Channel results reflect each platform or partner’s reporting methodology and should be interpreted independently. Cross-channel totals and blended acquisition costs are not used because attribution systems are not directly comparable. Meta clicks are link clicks. Spend per the FOREX.com budget tracker.</a:t>
+              <a:t>Channel results reflect each platform or partner’s reporting methodology and should be interpreted independently. Cross-channel totals and blended acquisition costs are not used because attribution systems are not directly comparable. Meta clicks are link clicks. Spend per the FOREX.com budget tracker. Channel lines are rounded to whole dollars; the total follows the FOREX.com budget tracker.</a:t>
             </a:r>
           </a:p>
         </p:txBody>
@@ -15366,7 +15382,7 @@
                 </a:solidFill>
                 <a:latin typeface="Georgia"/>
               </a:rPr>
-              <a:t>73 submitted applications at $403.81; the ad-position work is paying off.</a:t>
+              <a:t>Search delivered 73 applications, but CPA rose 20%; Track A Trust improved while the other tracks remain constrained.</a:t>
             </a:r>
           </a:p>
         </p:txBody>
@@ -17783,7 +17799,7 @@
                 </a:solidFill>
                 <a:latin typeface="Calibri"/>
               </a:rPr>
-              <a:t>How often our ads lose the auction to competitors fell to 58.7% (the account’s best), down from the 64-76% range every group sat in during June.</a:t>
+              <a:t>Impression share lost to rank fell to 58.7% (the account’s best), down from the 64-76% range every group sat in during June.</a:t>
             </a:r>
           </a:p>
           <a:p>
@@ -17959,7 +17975,7 @@
                 </a:solidFill>
                 <a:latin typeface="Calibri"/>
               </a:rPr>
-              <a:t>Authority and Platform still lose the auction to competitors 63.5% and 70.3% of the time, and Brand 79.0%, all worse than Trust’s 58.7%.</a:t>
+              <a:t>Authority and Platform still lose 63.5% and 70.3% of impression share due to rank, and Brand 79.0%, all worse than Trust’s 58.7%.</a:t>
             </a:r>
           </a:p>
           <a:p>
@@ -26544,7 +26560,7 @@
                           </a:solidFill>
                           <a:latin typeface="Calibri"/>
                         </a:rPr>
-                        <a:t>$8,829</a:t>
+                        <a:t>$9,711</a:t>
                       </a:r>
                     </a:p>
                   </a:txBody>
@@ -26590,7 +26606,7 @@
                           </a:solidFill>
                           <a:latin typeface="Calibri"/>
                         </a:rPr>
-                        <a:t>$383.88</a:t>
+                        <a:t>$422.22</a:t>
                       </a:r>
                     </a:p>
                   </a:txBody>
@@ -26638,7 +26654,7 @@
                           </a:solidFill>
                           <a:latin typeface="Calibri"/>
                         </a:rPr>
-                        <a:t>$7,956</a:t>
+                        <a:t>$8,752</a:t>
                       </a:r>
                     </a:p>
                   </a:txBody>
@@ -26684,7 +26700,7 @@
                           </a:solidFill>
                           <a:latin typeface="Calibri"/>
                         </a:rPr>
-                        <a:t>$530.40</a:t>
+                        <a:t>$583.47</a:t>
                       </a:r>
                     </a:p>
                   </a:txBody>
@@ -26732,7 +26748,7 @@
                           </a:solidFill>
                           <a:latin typeface="Calibri"/>
                         </a:rPr>
-                        <a:t>$8,033</a:t>
+                        <a:t>$8,837</a:t>
                       </a:r>
                     </a:p>
                   </a:txBody>
@@ -26778,7 +26794,7 @@
                           </a:solidFill>
                           <a:latin typeface="Calibri"/>
                         </a:rPr>
-                        <a:t>$365.15</a:t>
+                        <a:t>$401.68</a:t>
                       </a:r>
                     </a:p>
                   </a:txBody>
@@ -26826,7 +26842,7 @@
                           </a:solidFill>
                           <a:latin typeface="Calibri"/>
                         </a:rPr>
-                        <a:t>$2,895</a:t>
+                        <a:t>$3,185</a:t>
                       </a:r>
                     </a:p>
                   </a:txBody>
@@ -26872,7 +26888,7 @@
                           </a:solidFill>
                           <a:latin typeface="Calibri"/>
                         </a:rPr>
-                        <a:t>$144.76</a:t>
+                        <a:t>$159.25</a:t>
                       </a:r>
                     </a:p>
                   </a:txBody>
@@ -26920,7 +26936,7 @@
                           </a:solidFill>
                           <a:latin typeface="Calibri"/>
                         </a:rPr>
-                        <a:t>$902</a:t>
+                        <a:t>$992</a:t>
                       </a:r>
                     </a:p>
                   </a:txBody>
@@ -26983,42 +26999,7 @@
       </p:graphicFrame>
       <p:sp>
         <p:nvSpPr>
-          <p:cNvPr id="40" name="TextBox 39"/>
-          <p:cNvSpPr txBox="1"/>
-          <p:nvPr/>
-        </p:nvSpPr>
-        <p:spPr>
-          <a:xfrm>
-            <a:off x="457200" y="5532120"/>
-            <a:ext cx="5394960" cy="274320"/>
-          </a:xfrm>
-          <a:prstGeom prst="rect">
-            <a:avLst/>
-          </a:prstGeom>
-          <a:noFill/>
-        </p:spPr>
-        <p:txBody>
-          <a:bodyPr wrap="square" anchor="t" lIns="0" rIns="0" tIns="0" bIns="0">
-            <a:spAutoFit/>
-          </a:bodyPr>
-          <a:lstStyle/>
-          <a:p>
-            <a:pPr algn="l"/>
-            <a:r>
-              <a:rPr sz="750" b="0">
-                <a:solidFill>
-                  <a:srgbClr val="5A6072"/>
-                </a:solidFill>
-                <a:latin typeface="Calibri"/>
-              </a:rPr>
-              <a:t>Weekly figures are Azerion’s delivery figures; the month total appears in the tiles above.</a:t>
-            </a:r>
-          </a:p>
-        </p:txBody>
-      </p:sp>
-      <p:sp>
-        <p:nvSpPr>
-          <p:cNvPr id="41" name="Rectangle 40"/>
+          <p:cNvPr id="40" name="Rectangle 39"/>
           <p:cNvSpPr/>
           <p:nvPr/>
         </p:nvSpPr>
@@ -27064,7 +27045,7 @@
       </p:sp>
       <p:sp>
         <p:nvSpPr>
-          <p:cNvPr id="42" name="Rectangle 41"/>
+          <p:cNvPr id="41" name="Rectangle 40"/>
           <p:cNvSpPr/>
           <p:nvPr/>
         </p:nvSpPr>
@@ -27108,7 +27089,7 @@
       </p:sp>
       <p:sp>
         <p:nvSpPr>
-          <p:cNvPr id="43" name="TextBox 42"/>
+          <p:cNvPr id="42" name="TextBox 41"/>
           <p:cNvSpPr txBox="1"/>
           <p:nvPr/>
         </p:nvSpPr>
@@ -27143,7 +27124,7 @@
       </p:sp>
       <p:sp>
         <p:nvSpPr>
-          <p:cNvPr id="44" name="TextBox 43"/>
+          <p:cNvPr id="43" name="TextBox 42"/>
           <p:cNvSpPr txBox="1"/>
           <p:nvPr/>
         </p:nvSpPr>
@@ -27187,7 +27168,7 @@
                 </a:solidFill>
                 <a:latin typeface="Calibri"/>
               </a:rPr>
-              <a:t>The week of July 22-28 was the efficiency peak: 20 applications at $144.76 on reduced spend, evidence that tighter delivery converts better. Viewability rose 6.15 points to 64.95%.</a:t>
+              <a:t>July 22-28 produced the strongest weekly reported CPA. Confirm whether the result holds after reconciling conversion timing. Viewability rose 6.15 points to 64.95%.</a:t>
             </a:r>
           </a:p>
           <a:p>

</xml_diff>